<commit_message>
update workshop program details and lectures
</commit_message>
<xml_diff>
--- a/inst/docs/Lecture2.pptx
+++ b/inst/docs/Lecture2.pptx
@@ -223,7 +223,7 @@
           <a:p>
             <a:fld id="{5BA85917-96BC-A94E-B108-436BB51A4016}" type="datetimeFigureOut">
               <a:rPr lang="en-US" smtClean="0"/>
-              <a:t>4/12/25</a:t>
+              <a:t>4/7/26</a:t>
             </a:fld>
             <a:endParaRPr lang="en-US"/>
           </a:p>
@@ -6918,13 +6918,14 @@
           </a:p>
           <a:p>
             <a:r>
-              <a:rPr lang="en-US" dirty="0" err="1"/>
+              <a:rPr lang="en-US" err="1"/>
               <a:t>Physalia</a:t>
             </a:r>
             <a:r>
-              <a:rPr lang="en-US" dirty="0"/>
-              <a:t> 2025</a:t>
-            </a:r>
+              <a:rPr lang="en-US"/>
+              <a:t> 2026</a:t>
+            </a:r>
+            <a:endParaRPr lang="en-US" dirty="0"/>
           </a:p>
         </p:txBody>
       </p:sp>

</xml_diff>